<commit_message>
Ajusta documentación y avance de PWO
</commit_message>
<xml_diff>
--- a/entregables/avance/PWO_Presentacion_Avance_Gayoso_Gonzalez.pptx
+++ b/entregables/avance/PWO_Presentacion_Avance_Gayoso_Gonzalez.pptx
@@ -2,24 +2,24 @@
 <file path=ppt/presentation.xml><?xml version="1.0" encoding="utf-8"?>
 <p:presentation xmlns:p="http://schemas.openxmlformats.org/presentationml/2006/main">
   <p:sldMasterIdLst>
-    <p:sldMasterId xmlns:r="http://schemas.openxmlformats.org/officeDocument/2006/relationships" id="2147483648" r:id="Rfbb8ef519f644da5"/>
+    <p:sldMasterId xmlns:r="http://schemas.openxmlformats.org/officeDocument/2006/relationships" id="2147483648" r:id="R4c3ebc3da10d4ed5"/>
   </p:sldMasterIdLst>
   <p:notesMasterIdLst>
-    <p:notesMasterId xmlns:r="http://schemas.openxmlformats.org/officeDocument/2006/relationships" r:id="R2913a95c16454f61"/>
+    <p:notesMasterId xmlns:r="http://schemas.openxmlformats.org/officeDocument/2006/relationships" r:id="R288451aee8734f96"/>
   </p:notesMasterIdLst>
   <p:sldIdLst>
-    <p:sldId xmlns:r="http://schemas.openxmlformats.org/officeDocument/2006/relationships" id="256" r:id="R26163a0b553b45dc"/>
-    <p:sldId xmlns:r="http://schemas.openxmlformats.org/officeDocument/2006/relationships" id="257" r:id="Rd8f0e83b7eb74a96"/>
-    <p:sldId xmlns:r="http://schemas.openxmlformats.org/officeDocument/2006/relationships" id="258" r:id="R8b2f9810c32e45c3"/>
-    <p:sldId xmlns:r="http://schemas.openxmlformats.org/officeDocument/2006/relationships" id="259" r:id="R743266fb496a4e0d"/>
-    <p:sldId xmlns:r="http://schemas.openxmlformats.org/officeDocument/2006/relationships" id="260" r:id="Rf69290e2770d45f0"/>
-    <p:sldId xmlns:r="http://schemas.openxmlformats.org/officeDocument/2006/relationships" id="261" r:id="R26e7c8d5b12e42ac"/>
-    <p:sldId xmlns:r="http://schemas.openxmlformats.org/officeDocument/2006/relationships" id="262" r:id="Radbac690ba4a4737"/>
-    <p:sldId xmlns:r="http://schemas.openxmlformats.org/officeDocument/2006/relationships" id="263" r:id="R3935815abfdb4f1c"/>
-    <p:sldId xmlns:r="http://schemas.openxmlformats.org/officeDocument/2006/relationships" id="264" r:id="R395a416157cf4f53"/>
-    <p:sldId xmlns:r="http://schemas.openxmlformats.org/officeDocument/2006/relationships" id="265" r:id="R161a7ecea9694a36"/>
-    <p:sldId xmlns:r="http://schemas.openxmlformats.org/officeDocument/2006/relationships" id="266" r:id="Rb735c474181343bf"/>
-    <p:sldId xmlns:r="http://schemas.openxmlformats.org/officeDocument/2006/relationships" id="267" r:id="R3e0776adfbfc4486"/>
+    <p:sldId xmlns:r="http://schemas.openxmlformats.org/officeDocument/2006/relationships" id="256" r:id="R571ec3db39844a87"/>
+    <p:sldId xmlns:r="http://schemas.openxmlformats.org/officeDocument/2006/relationships" id="257" r:id="R601aeeb00aad4525"/>
+    <p:sldId xmlns:r="http://schemas.openxmlformats.org/officeDocument/2006/relationships" id="258" r:id="R98ff83345cd643ca"/>
+    <p:sldId xmlns:r="http://schemas.openxmlformats.org/officeDocument/2006/relationships" id="259" r:id="Rf0d50164a27f4b93"/>
+    <p:sldId xmlns:r="http://schemas.openxmlformats.org/officeDocument/2006/relationships" id="260" r:id="R1481784faf4d4a20"/>
+    <p:sldId xmlns:r="http://schemas.openxmlformats.org/officeDocument/2006/relationships" id="261" r:id="R1187c8d3834846e9"/>
+    <p:sldId xmlns:r="http://schemas.openxmlformats.org/officeDocument/2006/relationships" id="262" r:id="Rdbb5f307f23242d0"/>
+    <p:sldId xmlns:r="http://schemas.openxmlformats.org/officeDocument/2006/relationships" id="263" r:id="Re6fde380f2cb4520"/>
+    <p:sldId xmlns:r="http://schemas.openxmlformats.org/officeDocument/2006/relationships" id="264" r:id="R072a0f76d18241ee"/>
+    <p:sldId xmlns:r="http://schemas.openxmlformats.org/officeDocument/2006/relationships" id="265" r:id="Rec580186ecc24e16"/>
+    <p:sldId xmlns:r="http://schemas.openxmlformats.org/officeDocument/2006/relationships" id="266" r:id="R8d11566d22fa4bc3"/>
+    <p:sldId xmlns:r="http://schemas.openxmlformats.org/officeDocument/2006/relationships" id="267" r:id="Rcb1fa3e633ac45be"/>
   </p:sldIdLst>
   <p:sldSz cx="12192000" cy="6858000"/>
   <p:notesSz cx="6858000" cy="9144000"/>
@@ -628,7 +628,7 @@
           <a:lstStyle xmlns:a="http://schemas.openxmlformats.org/drawingml/2006/main"/>
           <a:p xmlns:a="http://schemas.openxmlformats.org/drawingml/2006/main">
             <a:r>
-              <a:t>Destacar cuatro discrepancias que afectan la reproducción. Para el avance, el artículo es la formulación académica y Python la referencia operacional; las diferencias se conservarán como decisiones experimentales trazables.</a:t>
+              <a:t>Destacar cuatro discrepancias que afectan la reproducción. Para el avance, el artículo y el código son fuentes distintas; sus diferencias se conservarán como decisiones experimentales trazables.</a:t>
             </a:r>
           </a:p>
           <a:p xmlns:a="http://schemas.openxmlformats.org/drawingml/2006/main">
@@ -1496,7 +1496,7 @@
   </p:cSld>
   <p:clrMap bg1="lt1" tx1="dk1" bg2="lt2" tx2="dk2" accent1="accent1" accent2="accent2" accent3="accent3" accent4="accent4" accent5="accent5" accent6="accent6" hlink="hlink" folHlink="folHlink"/>
   <p:sldLayoutIdLst>
-    <p:sldLayoutId xmlns:r="http://schemas.openxmlformats.org/officeDocument/2006/relationships" id="2147483649" r:id="Rba602c4401b3482b"/>
+    <p:sldLayoutId xmlns:r="http://schemas.openxmlformats.org/officeDocument/2006/relationships" id="2147483649" r:id="R6a63fc18c42849be"/>
   </p:sldLayoutIdLst>
   <p:txStyles>
     <p:titleStyle>
@@ -2044,6 +2044,7 @@
           </a:p>
         </c:rich>
       </c:tx>
+      <c:overlay val="0"/>
       <c:txPr>
         <a:bodyPr xmlns:a="http://schemas.openxmlformats.org/drawingml/2006/main" anchorCtr="1"/>
         <a:lstStyle xmlns:a="http://schemas.openxmlformats.org/drawingml/2006/main"/>
@@ -2172,6 +2173,7 @@
               </a:p>
             </c:rich>
           </c:tx>
+          <c:overlay val="0"/>
         </c:title>
         <c:numFmt formatCode="General"/>
         <c:majorTickMark val="none"/>
@@ -2198,9 +2200,6 @@
           </a:p>
         </c:txPr>
         <c:crossAx val="48672768"/>
-        <c:lblAlgn val="ctr"/>
-        <c:lblOffset val="100"/>
-        <c:noMultiLvlLbl val="0"/>
       </c:catAx>
       <c:valAx>
         <c:axId val="48672768"/>
@@ -2233,6 +2232,7 @@
               </a:p>
             </c:rich>
           </c:tx>
+          <c:overlay val="0"/>
         </c:title>
         <c:numFmt formatCode="General"/>
         <c:majorTickMark val="none"/>
@@ -2306,7 +2306,7 @@
           <p:cNvPr id="7" name="Title-3-1">
             <a:extLst xmlns:a="http://schemas.openxmlformats.org/drawingml/2006/main">
               <a:ext uri="{FF2B5EF4-FFF2-40B4-BE49-F238E27FC236}">
-                <a16:creationId xmlns:a16="http://schemas.microsoft.com/office/drawing/2014/main" id="{870E3779-C1AA-46C3-99AE-4D19C252ADD5}"/>
+                <a16:creationId xmlns:a16="http://schemas.microsoft.com/office/drawing/2014/main" id="{6FCB7AE2-D098-4B19-9ADE-F60936290724}"/>
               </a:ext>
             </a:extLst>
           </p:cNvPr>
@@ -2367,7 +2367,7 @@
           <p:cNvPr id="2" name="Subtitle-4-2">
             <a:extLst xmlns:a="http://schemas.openxmlformats.org/drawingml/2006/main">
               <a:ext uri="{FF2B5EF4-FFF2-40B4-BE49-F238E27FC236}">
-                <a16:creationId xmlns:a16="http://schemas.microsoft.com/office/drawing/2014/main" id="{3B89EC91-1F44-4644-BCD4-86C4C817DD87}"/>
+                <a16:creationId xmlns:a16="http://schemas.microsoft.com/office/drawing/2014/main" id="{C342B79D-9E3F-4021-985E-8D2985DFE7F1}"/>
               </a:ext>
             </a:extLst>
           </p:cNvPr>
@@ -2487,7 +2487,7 @@
           <p:cNvPr id="3" name="Subtitle-4-3">
             <a:extLst xmlns:a="http://schemas.openxmlformats.org/drawingml/2006/main">
               <a:ext uri="{FF2B5EF4-FFF2-40B4-BE49-F238E27FC236}">
-                <a16:creationId xmlns:a16="http://schemas.microsoft.com/office/drawing/2014/main" id="{8D9CC804-6E01-45DC-BFB3-BC685C902E6D}"/>
+                <a16:creationId xmlns:a16="http://schemas.microsoft.com/office/drawing/2014/main" id="{B78C638F-C30A-48F4-81A2-8E0C2A9DD9A0}"/>
               </a:ext>
             </a:extLst>
           </p:cNvPr>
@@ -2547,7 +2547,7 @@
           <p:cNvPr id="4" name="cover-alpha">
             <a:extLst xmlns:a="http://schemas.openxmlformats.org/drawingml/2006/main">
               <a:ext uri="{FF2B5EF4-FFF2-40B4-BE49-F238E27FC236}">
-                <a16:creationId xmlns:a16="http://schemas.microsoft.com/office/drawing/2014/main" id="{963D77F7-AF8C-43FA-BB61-74A30B33C239}"/>
+                <a16:creationId xmlns:a16="http://schemas.microsoft.com/office/drawing/2014/main" id="{2220395F-DBE0-4D5E-B658-71628704CD33}"/>
               </a:ext>
             </a:extLst>
           </p:cNvPr>
@@ -2580,7 +2580,7 @@
           <p:cNvPr id="5" name="cover-agent-1">
             <a:extLst xmlns:a="http://schemas.openxmlformats.org/drawingml/2006/main">
               <a:ext uri="{FF2B5EF4-FFF2-40B4-BE49-F238E27FC236}">
-                <a16:creationId xmlns:a16="http://schemas.microsoft.com/office/drawing/2014/main" id="{04D63230-EF0C-406C-B425-94354749EA71}"/>
+                <a16:creationId xmlns:a16="http://schemas.microsoft.com/office/drawing/2014/main" id="{9C0B1F18-4B6D-4BF5-8A47-137358A6D0C3}"/>
               </a:ext>
             </a:extLst>
           </p:cNvPr>
@@ -2613,7 +2613,7 @@
           <p:cNvPr id="6" name="cover-agent-2">
             <a:extLst xmlns:a="http://schemas.openxmlformats.org/drawingml/2006/main">
               <a:ext uri="{FF2B5EF4-FFF2-40B4-BE49-F238E27FC236}">
-                <a16:creationId xmlns:a16="http://schemas.microsoft.com/office/drawing/2014/main" id="{3FE49D94-8DEC-4C96-AF4E-3715495B1DAE}"/>
+                <a16:creationId xmlns:a16="http://schemas.microsoft.com/office/drawing/2014/main" id="{C01166C7-38F5-4A09-A60A-58786E578A64}"/>
               </a:ext>
             </a:extLst>
           </p:cNvPr>
@@ -2644,7 +2644,7 @@
     </p:spTree>
     <p:extLst>
       <p:ext uri="{BB962C8B-B14F-4D97-AF65-F5344CB8AC3E}">
-        <p14:creationId xmlns:p14="http://schemas.microsoft.com/office/powerpoint/2010/main" val="1119322667"/>
+        <p14:creationId xmlns:p14="http://schemas.microsoft.com/office/powerpoint/2010/main" val="1420146298"/>
       </p:ext>
     </p:extLst>
   </p:cSld>
@@ -2675,7 +2675,7 @@
           <p:cNvPr id="13" name="Slide-Number-Placeholder-3-2">
             <a:extLst xmlns:a="http://schemas.openxmlformats.org/drawingml/2006/main">
               <a:ext uri="{FF2B5EF4-FFF2-40B4-BE49-F238E27FC236}">
-                <a16:creationId xmlns:a16="http://schemas.microsoft.com/office/drawing/2014/main" id="{84459592-E0B2-48CE-946D-E168E695F6D7}"/>
+                <a16:creationId xmlns:a16="http://schemas.microsoft.com/office/drawing/2014/main" id="{0EC4A40B-7B9F-4A82-9873-AB81054055A0}"/>
               </a:ext>
             </a:extLst>
           </p:cNvPr>
@@ -2718,7 +2718,7 @@
           <p:cNvPr id="2" name="Title-10-3">
             <a:extLst xmlns:a="http://schemas.openxmlformats.org/drawingml/2006/main">
               <a:ext uri="{FF2B5EF4-FFF2-40B4-BE49-F238E27FC236}">
-                <a16:creationId xmlns:a16="http://schemas.microsoft.com/office/drawing/2014/main" id="{3F0177D5-467E-4D9D-A030-9B4C63BDC8B7}"/>
+                <a16:creationId xmlns:a16="http://schemas.microsoft.com/office/drawing/2014/main" id="{32269FE6-97AB-41EA-8EC9-078482FCE7A6}"/>
               </a:ext>
             </a:extLst>
           </p:cNvPr>
@@ -2768,7 +2768,7 @@
                 <a:ea typeface="Aptos"/>
                 <a:cs typeface="Aptos"/>
               </a:rPr>
-              <a:t>La implementación oficial converge en Sphere</a:t>
+              <a:t>La ejecución oficial reduce el fitness en Sphere</a:t>
             </a:r>
           </a:p>
         </p:txBody>
@@ -2778,7 +2778,7 @@
           <p:cNvPr id="3" name="Rounded-Rectangle-36-4">
             <a:extLst xmlns:a="http://schemas.openxmlformats.org/drawingml/2006/main">
               <a:ext uri="{FF2B5EF4-FFF2-40B4-BE49-F238E27FC236}">
-                <a16:creationId xmlns:a16="http://schemas.microsoft.com/office/drawing/2014/main" id="{59FDC6FA-52BD-4A02-A2A5-086B9D67D64C}"/>
+                <a16:creationId xmlns:a16="http://schemas.microsoft.com/office/drawing/2014/main" id="{0E90137A-BBFF-4313-8C9D-F2F0F642514E}"/>
               </a:ext>
             </a:extLst>
           </p:cNvPr>
@@ -2807,7 +2807,7 @@
           <p:cNvPr id="4" name="Content-Placeholder-9-5">
             <a:extLst xmlns:a="http://schemas.openxmlformats.org/drawingml/2006/main">
               <a:ext uri="{FF2B5EF4-FFF2-40B4-BE49-F238E27FC236}">
-                <a16:creationId xmlns:a16="http://schemas.microsoft.com/office/drawing/2014/main" id="{9D117985-3A87-40B4-B8A5-5DA0F42EB1F6}"/>
+                <a16:creationId xmlns:a16="http://schemas.microsoft.com/office/drawing/2014/main" id="{11E4BD4C-F590-4194-A0AE-AF9B7EB7227E}"/>
               </a:ext>
             </a:extLst>
           </p:cNvPr>
@@ -2867,7 +2867,7 @@
           <p:cNvPr id="5" name="Content-Placeholder-15-6">
             <a:extLst xmlns:a="http://schemas.openxmlformats.org/drawingml/2006/main">
               <a:ext uri="{FF2B5EF4-FFF2-40B4-BE49-F238E27FC236}">
-                <a16:creationId xmlns:a16="http://schemas.microsoft.com/office/drawing/2014/main" id="{C23F59FC-A9FF-406C-B0AB-884B3035DB4F}"/>
+                <a16:creationId xmlns:a16="http://schemas.microsoft.com/office/drawing/2014/main" id="{746E8E74-6289-4573-85E0-405BAA65AA6A}"/>
               </a:ext>
             </a:extLst>
           </p:cNvPr>
@@ -2928,7 +2928,7 @@
           <p:cNvPr id="6" name="Rounded-Rectangle-39-7">
             <a:extLst xmlns:a="http://schemas.openxmlformats.org/drawingml/2006/main">
               <a:ext uri="{FF2B5EF4-FFF2-40B4-BE49-F238E27FC236}">
-                <a16:creationId xmlns:a16="http://schemas.microsoft.com/office/drawing/2014/main" id="{B52E5DB0-58AA-4BF4-B740-336A403B2779}"/>
+                <a16:creationId xmlns:a16="http://schemas.microsoft.com/office/drawing/2014/main" id="{8BFC4C57-4D94-475D-8F03-11ED9BBEE7D9}"/>
               </a:ext>
             </a:extLst>
           </p:cNvPr>
@@ -2957,7 +2957,7 @@
           <p:cNvPr id="7" name="Content-Placeholder-9-8">
             <a:extLst xmlns:a="http://schemas.openxmlformats.org/drawingml/2006/main">
               <a:ext uri="{FF2B5EF4-FFF2-40B4-BE49-F238E27FC236}">
-                <a16:creationId xmlns:a16="http://schemas.microsoft.com/office/drawing/2014/main" id="{0A75E580-5583-4670-8ED4-1E04CD2E9F2C}"/>
+                <a16:creationId xmlns:a16="http://schemas.microsoft.com/office/drawing/2014/main" id="{0E70E94A-E5A5-4CCA-9713-77D6D8CF7548}"/>
               </a:ext>
             </a:extLst>
           </p:cNvPr>
@@ -3017,7 +3017,7 @@
           <p:cNvPr id="8" name="Content-Placeholder-15-9">
             <a:extLst xmlns:a="http://schemas.openxmlformats.org/drawingml/2006/main">
               <a:ext uri="{FF2B5EF4-FFF2-40B4-BE49-F238E27FC236}">
-                <a16:creationId xmlns:a16="http://schemas.microsoft.com/office/drawing/2014/main" id="{0EE1E561-C244-4202-850C-9CDBC8E8C8BE}"/>
+                <a16:creationId xmlns:a16="http://schemas.microsoft.com/office/drawing/2014/main" id="{57A4D7BD-FAD6-460A-B0FE-9DB67382F2D6}"/>
               </a:ext>
             </a:extLst>
           </p:cNvPr>
@@ -3078,7 +3078,7 @@
           <p:cNvPr id="9" name="Content-Placeholder-2-10">
             <a:extLst xmlns:a="http://schemas.openxmlformats.org/drawingml/2006/main">
               <a:ext uri="{FF2B5EF4-FFF2-40B4-BE49-F238E27FC236}">
-                <a16:creationId xmlns:a16="http://schemas.microsoft.com/office/drawing/2014/main" id="{C2A64D58-7D5B-44DA-B68F-8683814EF979}"/>
+                <a16:creationId xmlns:a16="http://schemas.microsoft.com/office/drawing/2014/main" id="{2853AEB7-1AEA-42B5-94CE-C2AC0685D65B}"/>
               </a:ext>
             </a:extLst>
           </p:cNvPr>
@@ -3145,7 +3145,7 @@
         </p:xfrm>
         <a:graphic xmlns:a="http://schemas.openxmlformats.org/drawingml/2006/main">
           <a:graphicData uri="http://schemas.openxmlformats.org/drawingml/2006/chart">
-            <c:chart xmlns:r="http://schemas.openxmlformats.org/officeDocument/2006/relationships" xmlns:c="http://schemas.openxmlformats.org/drawingml/2006/chart" r:id="R0217a607c32247d9"/>
+            <c:chart xmlns:r="http://schemas.openxmlformats.org/officeDocument/2006/relationships" xmlns:c="http://schemas.openxmlformats.org/drawingml/2006/chart" r:id="R16d43063bf664863"/>
           </a:graphicData>
         </a:graphic>
       </p:graphicFrame>
@@ -3154,7 +3154,7 @@
           <p:cNvPr id="11" name="accent-10">
             <a:extLst xmlns:a="http://schemas.openxmlformats.org/drawingml/2006/main">
               <a:ext uri="{FF2B5EF4-FFF2-40B4-BE49-F238E27FC236}">
-                <a16:creationId xmlns:a16="http://schemas.microsoft.com/office/drawing/2014/main" id="{5CD58D75-227F-41F6-AADF-4031E5D9277A}"/>
+                <a16:creationId xmlns:a16="http://schemas.microsoft.com/office/drawing/2014/main" id="{F17707E9-8A0E-41C3-83B8-7FDF243F2F41}"/>
               </a:ext>
             </a:extLst>
           </p:cNvPr>
@@ -3185,7 +3185,7 @@
           <p:cNvPr id="12" name="section-10">
             <a:extLst xmlns:a="http://schemas.openxmlformats.org/drawingml/2006/main">
               <a:ext uri="{FF2B5EF4-FFF2-40B4-BE49-F238E27FC236}">
-                <a16:creationId xmlns:a16="http://schemas.microsoft.com/office/drawing/2014/main" id="{005CC79D-5FB2-4DCD-A290-6700EDAD3AB1}"/>
+                <a16:creationId xmlns:a16="http://schemas.microsoft.com/office/drawing/2014/main" id="{3CA100B5-7715-4E43-B49B-1F27CD57CBAD}"/>
               </a:ext>
             </a:extLst>
           </p:cNvPr>
@@ -3239,7 +3239,7 @@
     </p:spTree>
     <p:extLst>
       <p:ext uri="{BB962C8B-B14F-4D97-AF65-F5344CB8AC3E}">
-        <p14:creationId xmlns:p14="http://schemas.microsoft.com/office/powerpoint/2010/main" val="438856045"/>
+        <p14:creationId xmlns:p14="http://schemas.microsoft.com/office/powerpoint/2010/main" val="334579760"/>
       </p:ext>
     </p:extLst>
   </p:cSld>
@@ -3270,7 +3270,7 @@
           <p:cNvPr id="8" name="Google-Shape-532-p58-2">
             <a:extLst xmlns:a="http://schemas.openxmlformats.org/drawingml/2006/main">
               <a:ext uri="{FF2B5EF4-FFF2-40B4-BE49-F238E27FC236}">
-                <a16:creationId xmlns:a16="http://schemas.microsoft.com/office/drawing/2014/main" id="{A039D5C8-A3C1-414E-AE3C-02CAC9211A81}"/>
+                <a16:creationId xmlns:a16="http://schemas.microsoft.com/office/drawing/2014/main" id="{A47D73D6-47BD-4B41-B0AF-A0C999E5E404}"/>
               </a:ext>
             </a:extLst>
           </p:cNvPr>
@@ -3315,7 +3315,7 @@
           <p:cNvPr id="2" name="Google-Shape-533-p58-3">
             <a:extLst xmlns:a="http://schemas.openxmlformats.org/drawingml/2006/main">
               <a:ext uri="{FF2B5EF4-FFF2-40B4-BE49-F238E27FC236}">
-                <a16:creationId xmlns:a16="http://schemas.microsoft.com/office/drawing/2014/main" id="{7576D286-5A02-4EA0-9C39-7AF7F62D9D0E}"/>
+                <a16:creationId xmlns:a16="http://schemas.microsoft.com/office/drawing/2014/main" id="{F9A49591-DAFA-41E3-B42B-0E828D7BF515}"/>
               </a:ext>
             </a:extLst>
           </p:cNvPr>
@@ -3375,7 +3375,7 @@
           <p:cNvPr id="3" name="Content-Placeholder-15-4">
             <a:extLst xmlns:a="http://schemas.openxmlformats.org/drawingml/2006/main">
               <a:ext uri="{FF2B5EF4-FFF2-40B4-BE49-F238E27FC236}">
-                <a16:creationId xmlns:a16="http://schemas.microsoft.com/office/drawing/2014/main" id="{5AACF87C-AF8E-422E-A127-E16CCA14FC72}"/>
+                <a16:creationId xmlns:a16="http://schemas.microsoft.com/office/drawing/2014/main" id="{3F597872-7280-43E4-B5D9-45030AD0AE61}"/>
               </a:ext>
             </a:extLst>
           </p:cNvPr>
@@ -3425,7 +3425,7 @@
                 <a:ea typeface="Aptos"/>
                 <a:cs typeface="Aptos"/>
               </a:rPr>
-              <a:t>Las diferencias no se corrigen silenciosamente: se documentan y se prueban como variantes.</a:t>
+              <a:t>Paper y código se tratan como fuentes distintas: las diferencias se documentan y se prueban como variantes.</a:t>
             </a:r>
           </a:p>
           <a:p xmlns:a="http://schemas.openxmlformats.org/drawingml/2006/main">
@@ -3465,7 +3465,7 @@
           <p:cNvPr id="4" name="differences-table-cover">
             <a:extLst xmlns:a="http://schemas.openxmlformats.org/drawingml/2006/main">
               <a:ext uri="{FF2B5EF4-FFF2-40B4-BE49-F238E27FC236}">
-                <a16:creationId xmlns:a16="http://schemas.microsoft.com/office/drawing/2014/main" id="{6A1A1DD3-BEC9-4C10-B29D-1957537272CD}"/>
+                <a16:creationId xmlns:a16="http://schemas.microsoft.com/office/drawing/2014/main" id="{941C9767-BC7A-4370-AD38-18C25350CA28}"/>
               </a:ext>
             </a:extLst>
           </p:cNvPr>
@@ -4012,7 +4012,7 @@
           <p:cNvPr id="6" name="accent-11">
             <a:extLst xmlns:a="http://schemas.openxmlformats.org/drawingml/2006/main">
               <a:ext uri="{FF2B5EF4-FFF2-40B4-BE49-F238E27FC236}">
-                <a16:creationId xmlns:a16="http://schemas.microsoft.com/office/drawing/2014/main" id="{09F442F2-0D29-44F6-A3CE-A5D6540BB7C0}"/>
+                <a16:creationId xmlns:a16="http://schemas.microsoft.com/office/drawing/2014/main" id="{EAE3E62A-316F-4E63-B0E0-B584BF32CC4F}"/>
               </a:ext>
             </a:extLst>
           </p:cNvPr>
@@ -4043,7 +4043,7 @@
           <p:cNvPr id="7" name="section-11">
             <a:extLst xmlns:a="http://schemas.openxmlformats.org/drawingml/2006/main">
               <a:ext uri="{FF2B5EF4-FFF2-40B4-BE49-F238E27FC236}">
-                <a16:creationId xmlns:a16="http://schemas.microsoft.com/office/drawing/2014/main" id="{4011CE45-5EF8-481E-B2D1-6FE8460020A3}"/>
+                <a16:creationId xmlns:a16="http://schemas.microsoft.com/office/drawing/2014/main" id="{8B78B4F6-FFDB-4A6E-9373-EAD9B781FAB9}"/>
               </a:ext>
             </a:extLst>
           </p:cNvPr>
@@ -4097,7 +4097,7 @@
     </p:spTree>
     <p:extLst>
       <p:ext uri="{BB962C8B-B14F-4D97-AF65-F5344CB8AC3E}">
-        <p14:creationId xmlns:p14="http://schemas.microsoft.com/office/powerpoint/2010/main" val="470469560"/>
+        <p14:creationId xmlns:p14="http://schemas.microsoft.com/office/powerpoint/2010/main" val="233240085"/>
       </p:ext>
     </p:extLst>
   </p:cSld>
@@ -4128,7 +4128,7 @@
           <p:cNvPr id="6" name="Title-3-1">
             <a:extLst xmlns:a="http://schemas.openxmlformats.org/drawingml/2006/main">
               <a:ext uri="{FF2B5EF4-FFF2-40B4-BE49-F238E27FC236}">
-                <a16:creationId xmlns:a16="http://schemas.microsoft.com/office/drawing/2014/main" id="{E2F8C6E1-5183-4475-A17F-F86AD4DE950C}"/>
+                <a16:creationId xmlns:a16="http://schemas.microsoft.com/office/drawing/2014/main" id="{DEEFA724-ACCA-40C1-943C-7CD28687DA0A}"/>
               </a:ext>
             </a:extLst>
           </p:cNvPr>
@@ -4189,7 +4189,7 @@
           <p:cNvPr id="2" name="Subtitle-4-2">
             <a:extLst xmlns:a="http://schemas.openxmlformats.org/drawingml/2006/main">
               <a:ext uri="{FF2B5EF4-FFF2-40B4-BE49-F238E27FC236}">
-                <a16:creationId xmlns:a16="http://schemas.microsoft.com/office/drawing/2014/main" id="{7206D274-6092-4589-BB12-F70FB531D717}"/>
+                <a16:creationId xmlns:a16="http://schemas.microsoft.com/office/drawing/2014/main" id="{B6EF7919-ECA5-4143-ADF6-3B80D2FBF429}"/>
               </a:ext>
             </a:extLst>
           </p:cNvPr>
@@ -4309,7 +4309,7 @@
           <p:cNvPr id="3" name="Subtitle-4-3">
             <a:extLst xmlns:a="http://schemas.openxmlformats.org/drawingml/2006/main">
               <a:ext uri="{FF2B5EF4-FFF2-40B4-BE49-F238E27FC236}">
-                <a16:creationId xmlns:a16="http://schemas.microsoft.com/office/drawing/2014/main" id="{872D4CEA-1344-4BCD-982E-88B63A648CBC}"/>
+                <a16:creationId xmlns:a16="http://schemas.microsoft.com/office/drawing/2014/main" id="{2E18BDBC-FAE5-42A2-B411-766DB8BC6A10}"/>
               </a:ext>
             </a:extLst>
           </p:cNvPr>
@@ -4369,7 +4369,7 @@
           <p:cNvPr id="4" name="final-callout">
             <a:extLst xmlns:a="http://schemas.openxmlformats.org/drawingml/2006/main">
               <a:ext uri="{FF2B5EF4-FFF2-40B4-BE49-F238E27FC236}">
-                <a16:creationId xmlns:a16="http://schemas.microsoft.com/office/drawing/2014/main" id="{001201FF-5B17-4105-9F99-31FD63733141}"/>
+                <a16:creationId xmlns:a16="http://schemas.microsoft.com/office/drawing/2014/main" id="{E160ABAB-196F-47A0-B819-3EF7E80C1869}"/>
               </a:ext>
             </a:extLst>
           </p:cNvPr>
@@ -4404,7 +4404,7 @@
           <p:cNvPr id="5" name="final-callout-text">
             <a:extLst xmlns:a="http://schemas.openxmlformats.org/drawingml/2006/main">
               <a:ext uri="{FF2B5EF4-FFF2-40B4-BE49-F238E27FC236}">
-                <a16:creationId xmlns:a16="http://schemas.microsoft.com/office/drawing/2014/main" id="{2AC6628E-3085-4505-A497-8E977E891F02}"/>
+                <a16:creationId xmlns:a16="http://schemas.microsoft.com/office/drawing/2014/main" id="{D6EA4C06-7B16-4DB5-8493-9F602C3F9994}"/>
               </a:ext>
             </a:extLst>
           </p:cNvPr>
@@ -4504,7 +4504,7 @@
     </p:spTree>
     <p:extLst>
       <p:ext uri="{BB962C8B-B14F-4D97-AF65-F5344CB8AC3E}">
-        <p14:creationId xmlns:p14="http://schemas.microsoft.com/office/powerpoint/2010/main" val="1268770714"/>
+        <p14:creationId xmlns:p14="http://schemas.microsoft.com/office/powerpoint/2010/main" val="685525869"/>
       </p:ext>
     </p:extLst>
   </p:cSld>
@@ -4535,7 +4535,7 @@
           <p:cNvPr id="7" name="Google-Shape-532-p58-2">
             <a:extLst xmlns:a="http://schemas.openxmlformats.org/drawingml/2006/main">
               <a:ext uri="{FF2B5EF4-FFF2-40B4-BE49-F238E27FC236}">
-                <a16:creationId xmlns:a16="http://schemas.microsoft.com/office/drawing/2014/main" id="{42F2DCAA-08CA-407B-9E40-DA85DA5D6CC7}"/>
+                <a16:creationId xmlns:a16="http://schemas.microsoft.com/office/drawing/2014/main" id="{3C4275C3-2BC2-42D4-8602-A8A35F456EBC}"/>
               </a:ext>
             </a:extLst>
           </p:cNvPr>
@@ -4580,7 +4580,7 @@
           <p:cNvPr id="2" name="Google-Shape-533-p58-3">
             <a:extLst xmlns:a="http://schemas.openxmlformats.org/drawingml/2006/main">
               <a:ext uri="{FF2B5EF4-FFF2-40B4-BE49-F238E27FC236}">
-                <a16:creationId xmlns:a16="http://schemas.microsoft.com/office/drawing/2014/main" id="{770B3CFC-C29A-47EC-8ADE-0CEF7FCEC28C}"/>
+                <a16:creationId xmlns:a16="http://schemas.microsoft.com/office/drawing/2014/main" id="{0A444EBD-9108-4608-8F14-3B43A3ADE760}"/>
               </a:ext>
             </a:extLst>
           </p:cNvPr>
@@ -4640,7 +4640,7 @@
           <p:cNvPr id="3" name="Google-Shape-534-p58-4">
             <a:extLst xmlns:a="http://schemas.openxmlformats.org/drawingml/2006/main">
               <a:ext uri="{FF2B5EF4-FFF2-40B4-BE49-F238E27FC236}">
-                <a16:creationId xmlns:a16="http://schemas.microsoft.com/office/drawing/2014/main" id="{D1826777-E294-4286-94A9-8B2EEDD23399}"/>
+                <a16:creationId xmlns:a16="http://schemas.microsoft.com/office/drawing/2014/main" id="{50D377C9-9F0A-4395-9C25-B1F943477D52}"/>
               </a:ext>
             </a:extLst>
           </p:cNvPr>
@@ -4731,7 +4731,7 @@
           <p:cNvPr id="4" name="Content-Placeholder-3-5">
             <a:extLst xmlns:a="http://schemas.openxmlformats.org/drawingml/2006/main">
               <a:ext uri="{FF2B5EF4-FFF2-40B4-BE49-F238E27FC236}">
-                <a16:creationId xmlns:a16="http://schemas.microsoft.com/office/drawing/2014/main" id="{F07BE17F-644A-48CF-BD25-8C855AB06FB5}"/>
+                <a16:creationId xmlns:a16="http://schemas.microsoft.com/office/drawing/2014/main" id="{01C00F5A-06B0-4BAF-8047-1D1401BBD213}"/>
               </a:ext>
             </a:extLst>
           </p:cNvPr>
@@ -4824,7 +4824,7 @@
           <p:cNvPr id="5" name="accent-2">
             <a:extLst xmlns:a="http://schemas.openxmlformats.org/drawingml/2006/main">
               <a:ext uri="{FF2B5EF4-FFF2-40B4-BE49-F238E27FC236}">
-                <a16:creationId xmlns:a16="http://schemas.microsoft.com/office/drawing/2014/main" id="{C7F66233-0E36-422D-AF8B-A308BD6307B0}"/>
+                <a16:creationId xmlns:a16="http://schemas.microsoft.com/office/drawing/2014/main" id="{404767FC-A4B2-4C19-BC0A-07ACBA799851}"/>
               </a:ext>
             </a:extLst>
           </p:cNvPr>
@@ -4855,7 +4855,7 @@
           <p:cNvPr id="6" name="section-2">
             <a:extLst xmlns:a="http://schemas.openxmlformats.org/drawingml/2006/main">
               <a:ext uri="{FF2B5EF4-FFF2-40B4-BE49-F238E27FC236}">
-                <a16:creationId xmlns:a16="http://schemas.microsoft.com/office/drawing/2014/main" id="{8B05F599-0B5F-4618-95F8-2DAB1062E19F}"/>
+                <a16:creationId xmlns:a16="http://schemas.microsoft.com/office/drawing/2014/main" id="{C8AA9148-F1A2-44F2-8AD4-9374FDE25B59}"/>
               </a:ext>
             </a:extLst>
           </p:cNvPr>
@@ -4909,7 +4909,7 @@
     </p:spTree>
     <p:extLst>
       <p:ext uri="{BB962C8B-B14F-4D97-AF65-F5344CB8AC3E}">
-        <p14:creationId xmlns:p14="http://schemas.microsoft.com/office/powerpoint/2010/main" val="1029416482"/>
+        <p14:creationId xmlns:p14="http://schemas.microsoft.com/office/powerpoint/2010/main" val="1207972482"/>
       </p:ext>
     </p:extLst>
   </p:cSld>
@@ -4940,7 +4940,7 @@
           <p:cNvPr id="16" name="Slide-Number-Placeholder-3-2">
             <a:extLst xmlns:a="http://schemas.openxmlformats.org/drawingml/2006/main">
               <a:ext uri="{FF2B5EF4-FFF2-40B4-BE49-F238E27FC236}">
-                <a16:creationId xmlns:a16="http://schemas.microsoft.com/office/drawing/2014/main" id="{E00C94DB-1351-4AB1-BF01-32CD5F778D69}"/>
+                <a16:creationId xmlns:a16="http://schemas.microsoft.com/office/drawing/2014/main" id="{71C05C56-D661-40C3-B55E-5DA526EC5F57}"/>
               </a:ext>
             </a:extLst>
           </p:cNvPr>
@@ -4983,7 +4983,7 @@
           <p:cNvPr id="2" name="Title-10-3">
             <a:extLst xmlns:a="http://schemas.openxmlformats.org/drawingml/2006/main">
               <a:ext uri="{FF2B5EF4-FFF2-40B4-BE49-F238E27FC236}">
-                <a16:creationId xmlns:a16="http://schemas.microsoft.com/office/drawing/2014/main" id="{A8526A2A-E185-4F4D-A8E8-4F2C267E3653}"/>
+                <a16:creationId xmlns:a16="http://schemas.microsoft.com/office/drawing/2014/main" id="{64C78C5C-05C6-4010-80E3-93432F986652}"/>
               </a:ext>
             </a:extLst>
           </p:cNvPr>
@@ -5065,7 +5065,7 @@
           <p:cNvPr id="4" name="Google-Shape-2260-p159-5">
             <a:extLst xmlns:a="http://schemas.openxmlformats.org/drawingml/2006/main">
               <a:ext uri="{FF2B5EF4-FFF2-40B4-BE49-F238E27FC236}">
-                <a16:creationId xmlns:a16="http://schemas.microsoft.com/office/drawing/2014/main" id="{F5B33A20-EE67-4A62-AEAF-548767C14F20}"/>
+                <a16:creationId xmlns:a16="http://schemas.microsoft.com/office/drawing/2014/main" id="{A8BA45C1-3FBB-4757-9C04-3B1FFE4F3197}"/>
               </a:ext>
             </a:extLst>
           </p:cNvPr>
@@ -5092,7 +5092,7 @@
           <p:cNvPr id="5" name="Google-Shape-2261-p159-6">
             <a:extLst xmlns:a="http://schemas.openxmlformats.org/drawingml/2006/main">
               <a:ext uri="{FF2B5EF4-FFF2-40B4-BE49-F238E27FC236}">
-                <a16:creationId xmlns:a16="http://schemas.microsoft.com/office/drawing/2014/main" id="{4A584F74-5B21-41D5-B32B-A50FC70217D2}"/>
+                <a16:creationId xmlns:a16="http://schemas.microsoft.com/office/drawing/2014/main" id="{AD6E709A-5A9F-45FB-BDAB-822BF864077F}"/>
               </a:ext>
             </a:extLst>
           </p:cNvPr>
@@ -5119,7 +5119,7 @@
           <p:cNvPr id="6" name="Google-Shape-2262-p159-7">
             <a:extLst xmlns:a="http://schemas.openxmlformats.org/drawingml/2006/main">
               <a:ext uri="{FF2B5EF4-FFF2-40B4-BE49-F238E27FC236}">
-                <a16:creationId xmlns:a16="http://schemas.microsoft.com/office/drawing/2014/main" id="{3E6693C6-5168-4464-9EC3-72B686CC4216}"/>
+                <a16:creationId xmlns:a16="http://schemas.microsoft.com/office/drawing/2014/main" id="{4B7D05D2-1FD1-4D11-B35C-C5F38D3C0CD4}"/>
               </a:ext>
             </a:extLst>
           </p:cNvPr>
@@ -5146,7 +5146,7 @@
           <p:cNvPr id="7" name="Content-Placeholder-15-8">
             <a:extLst xmlns:a="http://schemas.openxmlformats.org/drawingml/2006/main">
               <a:ext uri="{FF2B5EF4-FFF2-40B4-BE49-F238E27FC236}">
-                <a16:creationId xmlns:a16="http://schemas.microsoft.com/office/drawing/2014/main" id="{A73FD140-1859-41D0-88CD-9283F9DF0C2B}"/>
+                <a16:creationId xmlns:a16="http://schemas.microsoft.com/office/drawing/2014/main" id="{843BA257-543B-4A92-A4BF-D947D19CF073}"/>
               </a:ext>
             </a:extLst>
           </p:cNvPr>
@@ -5206,7 +5206,7 @@
           <p:cNvPr id="8" name="Content-Placeholder-15-9">
             <a:extLst xmlns:a="http://schemas.openxmlformats.org/drawingml/2006/main">
               <a:ext uri="{FF2B5EF4-FFF2-40B4-BE49-F238E27FC236}">
-                <a16:creationId xmlns:a16="http://schemas.microsoft.com/office/drawing/2014/main" id="{2FA66412-73F0-436F-9DA2-8F3ABA851964}"/>
+                <a16:creationId xmlns:a16="http://schemas.microsoft.com/office/drawing/2014/main" id="{13901217-3DF3-4A3B-A51D-4E52C8BF066F}"/>
               </a:ext>
             </a:extLst>
           </p:cNvPr>
@@ -5266,7 +5266,7 @@
           <p:cNvPr id="9" name="Content-Placeholder-15-10">
             <a:extLst xmlns:a="http://schemas.openxmlformats.org/drawingml/2006/main">
               <a:ext uri="{FF2B5EF4-FFF2-40B4-BE49-F238E27FC236}">
-                <a16:creationId xmlns:a16="http://schemas.microsoft.com/office/drawing/2014/main" id="{F23F1240-C592-4C20-AD7F-58C7CA045360}"/>
+                <a16:creationId xmlns:a16="http://schemas.microsoft.com/office/drawing/2014/main" id="{1B000218-1A21-4C38-BE9D-819D09564461}"/>
               </a:ext>
             </a:extLst>
           </p:cNvPr>
@@ -5326,7 +5326,7 @@
           <p:cNvPr id="10" name="Text-Placeholder-16-11">
             <a:extLst xmlns:a="http://schemas.openxmlformats.org/drawingml/2006/main">
               <a:ext uri="{FF2B5EF4-FFF2-40B4-BE49-F238E27FC236}">
-                <a16:creationId xmlns:a16="http://schemas.microsoft.com/office/drawing/2014/main" id="{6D28EE02-57C4-469F-852E-83B15C8741C4}"/>
+                <a16:creationId xmlns:a16="http://schemas.microsoft.com/office/drawing/2014/main" id="{54090E36-C7F7-437D-A82A-127B0CDC2CDB}"/>
               </a:ext>
             </a:extLst>
           </p:cNvPr>
@@ -5416,7 +5416,7 @@
           <p:cNvPr id="11" name="Text-Placeholder-16-12">
             <a:extLst xmlns:a="http://schemas.openxmlformats.org/drawingml/2006/main">
               <a:ext uri="{FF2B5EF4-FFF2-40B4-BE49-F238E27FC236}">
-                <a16:creationId xmlns:a16="http://schemas.microsoft.com/office/drawing/2014/main" id="{91BAB09C-9828-45BF-A658-80B9A727A311}"/>
+                <a16:creationId xmlns:a16="http://schemas.microsoft.com/office/drawing/2014/main" id="{519B8602-1D95-45C7-8B01-8545227A7135}"/>
               </a:ext>
             </a:extLst>
           </p:cNvPr>
@@ -5506,7 +5506,7 @@
           <p:cNvPr id="12" name="Text-Placeholder-16-13">
             <a:extLst xmlns:a="http://schemas.openxmlformats.org/drawingml/2006/main">
               <a:ext uri="{FF2B5EF4-FFF2-40B4-BE49-F238E27FC236}">
-                <a16:creationId xmlns:a16="http://schemas.microsoft.com/office/drawing/2014/main" id="{DDB76126-9DC7-42AF-AD09-62E242083916}"/>
+                <a16:creationId xmlns:a16="http://schemas.microsoft.com/office/drawing/2014/main" id="{4733E195-FE0E-410E-8BD6-6C556CEE17F5}"/>
               </a:ext>
             </a:extLst>
           </p:cNvPr>
@@ -5596,7 +5596,7 @@
           <p:cNvPr id="13" name="accent-3">
             <a:extLst xmlns:a="http://schemas.openxmlformats.org/drawingml/2006/main">
               <a:ext uri="{FF2B5EF4-FFF2-40B4-BE49-F238E27FC236}">
-                <a16:creationId xmlns:a16="http://schemas.microsoft.com/office/drawing/2014/main" id="{1243242E-6F27-4616-A033-ACFCA6731319}"/>
+                <a16:creationId xmlns:a16="http://schemas.microsoft.com/office/drawing/2014/main" id="{9B824C6F-E7EF-42BF-BC26-0E8FA99B66EC}"/>
               </a:ext>
             </a:extLst>
           </p:cNvPr>
@@ -5627,7 +5627,7 @@
           <p:cNvPr id="14" name="section-3">
             <a:extLst xmlns:a="http://schemas.openxmlformats.org/drawingml/2006/main">
               <a:ext uri="{FF2B5EF4-FFF2-40B4-BE49-F238E27FC236}">
-                <a16:creationId xmlns:a16="http://schemas.microsoft.com/office/drawing/2014/main" id="{CA3791B2-D140-42CD-8EC8-ED83142455FC}"/>
+                <a16:creationId xmlns:a16="http://schemas.microsoft.com/office/drawing/2014/main" id="{40E4235B-3A57-4408-99BC-836AFAAE2F0D}"/>
               </a:ext>
             </a:extLst>
           </p:cNvPr>
@@ -5683,7 +5683,7 @@
           <p:cNvPr id="15" name="domain-note">
             <a:extLst xmlns:a="http://schemas.openxmlformats.org/drawingml/2006/main">
               <a:ext uri="{FF2B5EF4-FFF2-40B4-BE49-F238E27FC236}">
-                <a16:creationId xmlns:a16="http://schemas.microsoft.com/office/drawing/2014/main" id="{C8040AA0-910A-493D-B54A-699F6C46D5D7}"/>
+                <a16:creationId xmlns:a16="http://schemas.microsoft.com/office/drawing/2014/main" id="{36687155-19DB-4421-947D-5A282B248016}"/>
               </a:ext>
             </a:extLst>
           </p:cNvPr>
@@ -5737,7 +5737,7 @@
     </p:spTree>
     <p:extLst>
       <p:ext uri="{BB962C8B-B14F-4D97-AF65-F5344CB8AC3E}">
-        <p14:creationId xmlns:p14="http://schemas.microsoft.com/office/powerpoint/2010/main" val="875165079"/>
+        <p14:creationId xmlns:p14="http://schemas.microsoft.com/office/powerpoint/2010/main" val="270372633"/>
       </p:ext>
     </p:extLst>
   </p:cSld>
@@ -5768,7 +5768,7 @@
           <p:cNvPr id="7" name="Google-Shape-532-p58-2">
             <a:extLst xmlns:a="http://schemas.openxmlformats.org/drawingml/2006/main">
               <a:ext uri="{FF2B5EF4-FFF2-40B4-BE49-F238E27FC236}">
-                <a16:creationId xmlns:a16="http://schemas.microsoft.com/office/drawing/2014/main" id="{F3B29BBE-3466-4CCD-815A-FBDC7058EAAD}"/>
+                <a16:creationId xmlns:a16="http://schemas.microsoft.com/office/drawing/2014/main" id="{2D413B96-12CB-446E-B49A-88DF944727EF}"/>
               </a:ext>
             </a:extLst>
           </p:cNvPr>
@@ -5813,7 +5813,7 @@
           <p:cNvPr id="2" name="Google-Shape-533-p58-3">
             <a:extLst xmlns:a="http://schemas.openxmlformats.org/drawingml/2006/main">
               <a:ext uri="{FF2B5EF4-FFF2-40B4-BE49-F238E27FC236}">
-                <a16:creationId xmlns:a16="http://schemas.microsoft.com/office/drawing/2014/main" id="{C2E2CC93-65BE-4D02-9954-E127C4CA824B}"/>
+                <a16:creationId xmlns:a16="http://schemas.microsoft.com/office/drawing/2014/main" id="{227EDFCB-D196-45CD-830B-414270234044}"/>
               </a:ext>
             </a:extLst>
           </p:cNvPr>
@@ -5873,7 +5873,7 @@
           <p:cNvPr id="3" name="Google-Shape-534-p58-4">
             <a:extLst xmlns:a="http://schemas.openxmlformats.org/drawingml/2006/main">
               <a:ext uri="{FF2B5EF4-FFF2-40B4-BE49-F238E27FC236}">
-                <a16:creationId xmlns:a16="http://schemas.microsoft.com/office/drawing/2014/main" id="{AB82A5D7-6E44-4C84-A58C-0956C3A3EA59}"/>
+                <a16:creationId xmlns:a16="http://schemas.microsoft.com/office/drawing/2014/main" id="{FD8BA2B8-4998-4D65-9C42-9D78A2F43003}"/>
               </a:ext>
             </a:extLst>
           </p:cNvPr>
@@ -5955,7 +5955,7 @@
               </a:rPr>
               <a:t>a(t) = 2(1 − t/T)
 L(t) = |0.04 / a(t)|
-Cada agente cercano al alfa aporta un voto de 0.04 a R(t).</a:t>
+Cada agente cuyo fitness satisface la condición aporta un voto de 0.04 a R(t).</a:t>
             </a:r>
           </a:p>
         </p:txBody>
@@ -5965,7 +5965,7 @@
           <p:cNvPr id="4" name="Content-Placeholder-3-5">
             <a:extLst xmlns:a="http://schemas.openxmlformats.org/drawingml/2006/main">
               <a:ext uri="{FF2B5EF4-FFF2-40B4-BE49-F238E27FC236}">
-                <a16:creationId xmlns:a16="http://schemas.microsoft.com/office/drawing/2014/main" id="{CD6ABEFB-556C-4066-A0B7-F20CE5E6AEAF}"/>
+                <a16:creationId xmlns:a16="http://schemas.microsoft.com/office/drawing/2014/main" id="{98B5DCCF-B67B-401C-9807-96CF07D9EFA5}"/>
               </a:ext>
             </a:extLst>
           </p:cNvPr>
@@ -6057,7 +6057,7 @@
           <p:cNvPr id="5" name="accent-4">
             <a:extLst xmlns:a="http://schemas.openxmlformats.org/drawingml/2006/main">
               <a:ext uri="{FF2B5EF4-FFF2-40B4-BE49-F238E27FC236}">
-                <a16:creationId xmlns:a16="http://schemas.microsoft.com/office/drawing/2014/main" id="{C2607628-9782-45D2-AC87-006FCE99ED30}"/>
+                <a16:creationId xmlns:a16="http://schemas.microsoft.com/office/drawing/2014/main" id="{2CC80433-EC0A-4991-B2A0-5E5676F8627D}"/>
               </a:ext>
             </a:extLst>
           </p:cNvPr>
@@ -6088,7 +6088,7 @@
           <p:cNvPr id="6" name="section-4">
             <a:extLst xmlns:a="http://schemas.openxmlformats.org/drawingml/2006/main">
               <a:ext uri="{FF2B5EF4-FFF2-40B4-BE49-F238E27FC236}">
-                <a16:creationId xmlns:a16="http://schemas.microsoft.com/office/drawing/2014/main" id="{89FB0A63-90B9-427B-9B6D-2B6559189650}"/>
+                <a16:creationId xmlns:a16="http://schemas.microsoft.com/office/drawing/2014/main" id="{AD85DE79-7756-4DDD-AE28-B94AD26D309A}"/>
               </a:ext>
             </a:extLst>
           </p:cNvPr>
@@ -6142,7 +6142,7 @@
     </p:spTree>
     <p:extLst>
       <p:ext uri="{BB962C8B-B14F-4D97-AF65-F5344CB8AC3E}">
-        <p14:creationId xmlns:p14="http://schemas.microsoft.com/office/powerpoint/2010/main" val="162131713"/>
+        <p14:creationId xmlns:p14="http://schemas.microsoft.com/office/powerpoint/2010/main" val="885666777"/>
       </p:ext>
     </p:extLst>
   </p:cSld>
@@ -6173,7 +6173,7 @@
           <p:cNvPr id="11" name="Google-Shape-532-p58-2">
             <a:extLst xmlns:a="http://schemas.openxmlformats.org/drawingml/2006/main">
               <a:ext uri="{FF2B5EF4-FFF2-40B4-BE49-F238E27FC236}">
-                <a16:creationId xmlns:a16="http://schemas.microsoft.com/office/drawing/2014/main" id="{9CFD75FD-B843-4C6C-B3A4-0E6C545BC080}"/>
+                <a16:creationId xmlns:a16="http://schemas.microsoft.com/office/drawing/2014/main" id="{5881EEF8-9144-4612-9791-A6D2151780E6}"/>
               </a:ext>
             </a:extLst>
           </p:cNvPr>
@@ -6218,7 +6218,7 @@
           <p:cNvPr id="2" name="Google-Shape-533-p58-3">
             <a:extLst xmlns:a="http://schemas.openxmlformats.org/drawingml/2006/main">
               <a:ext uri="{FF2B5EF4-FFF2-40B4-BE49-F238E27FC236}">
-                <a16:creationId xmlns:a16="http://schemas.microsoft.com/office/drawing/2014/main" id="{D222DF5B-C316-4395-82FB-9201523AB268}"/>
+                <a16:creationId xmlns:a16="http://schemas.microsoft.com/office/drawing/2014/main" id="{2D26A893-A3EB-4B25-9D33-F587F41FF329}"/>
               </a:ext>
             </a:extLst>
           </p:cNvPr>
@@ -6278,7 +6278,7 @@
           <p:cNvPr id="3" name="Google-Shape-534-p58-4">
             <a:extLst xmlns:a="http://schemas.openxmlformats.org/drawingml/2006/main">
               <a:ext uri="{FF2B5EF4-FFF2-40B4-BE49-F238E27FC236}">
-                <a16:creationId xmlns:a16="http://schemas.microsoft.com/office/drawing/2014/main" id="{E36AB741-11C9-4CB8-9E6A-A4D4EE9F4552}"/>
+                <a16:creationId xmlns:a16="http://schemas.microsoft.com/office/drawing/2014/main" id="{E149DAFF-66CB-4CA9-92EE-1984A678A45D}"/>
               </a:ext>
             </a:extLst>
           </p:cNvPr>
@@ -6369,7 +6369,7 @@
           <p:cNvPr id="4" name="Content-Placeholder-1-5">
             <a:extLst xmlns:a="http://schemas.openxmlformats.org/drawingml/2006/main">
               <a:ext uri="{FF2B5EF4-FFF2-40B4-BE49-F238E27FC236}">
-                <a16:creationId xmlns:a16="http://schemas.microsoft.com/office/drawing/2014/main" id="{A895A92A-F671-463A-8C47-ECE3EA7662D2}"/>
+                <a16:creationId xmlns:a16="http://schemas.microsoft.com/office/drawing/2014/main" id="{87A638A1-F59F-4AE6-A129-B48B7485EA9C}"/>
               </a:ext>
             </a:extLst>
           </p:cNvPr>
@@ -6459,7 +6459,7 @@
           <p:cNvPr id="5" name="Content-Placeholder-2-6">
             <a:extLst xmlns:a="http://schemas.openxmlformats.org/drawingml/2006/main">
               <a:ext uri="{FF2B5EF4-FFF2-40B4-BE49-F238E27FC236}">
-                <a16:creationId xmlns:a16="http://schemas.microsoft.com/office/drawing/2014/main" id="{573B4155-7BD9-4AA6-9393-E05305E56739}"/>
+                <a16:creationId xmlns:a16="http://schemas.microsoft.com/office/drawing/2014/main" id="{C09B8643-FA63-4371-9046-538B86C1A149}"/>
               </a:ext>
             </a:extLst>
           </p:cNvPr>
@@ -6549,7 +6549,7 @@
           <p:cNvPr id="6" name="accent-5">
             <a:extLst xmlns:a="http://schemas.openxmlformats.org/drawingml/2006/main">
               <a:ext uri="{FF2B5EF4-FFF2-40B4-BE49-F238E27FC236}">
-                <a16:creationId xmlns:a16="http://schemas.microsoft.com/office/drawing/2014/main" id="{A1166BBE-44F5-4CDB-B54C-9D60A7C2F133}"/>
+                <a16:creationId xmlns:a16="http://schemas.microsoft.com/office/drawing/2014/main" id="{603552BD-EA5D-44AC-AA62-C754DE561F18}"/>
               </a:ext>
             </a:extLst>
           </p:cNvPr>
@@ -6580,7 +6580,7 @@
           <p:cNvPr id="7" name="section-5">
             <a:extLst xmlns:a="http://schemas.openxmlformats.org/drawingml/2006/main">
               <a:ext uri="{FF2B5EF4-FFF2-40B4-BE49-F238E27FC236}">
-                <a16:creationId xmlns:a16="http://schemas.microsoft.com/office/drawing/2014/main" id="{683C65B8-FEB1-489F-B8A4-0DA6A3470FD4}"/>
+                <a16:creationId xmlns:a16="http://schemas.microsoft.com/office/drawing/2014/main" id="{61C7A730-95E2-4BD8-B662-56421D22E3A9}"/>
               </a:ext>
             </a:extLst>
           </p:cNvPr>
@@ -6636,7 +6636,7 @@
           <p:cNvPr id="8" name="">
             <a:extLst xmlns:a="http://schemas.openxmlformats.org/drawingml/2006/main">
               <a:ext uri="{FF2B5EF4-FFF2-40B4-BE49-F238E27FC236}">
-                <a16:creationId xmlns:a16="http://schemas.microsoft.com/office/drawing/2014/main" id="{41ACA096-7EC4-4F78-97D8-E0995C884914}"/>
+                <a16:creationId xmlns:a16="http://schemas.microsoft.com/office/drawing/2014/main" id="{84FFC528-26FC-400A-B2F5-C1B705967839}"/>
               </a:ext>
             </a:extLst>
           </p:cNvPr>
@@ -6694,7 +6694,7 @@
           <p:cNvPr id="9" name="">
             <a:extLst xmlns:a="http://schemas.openxmlformats.org/drawingml/2006/main">
               <a:ext uri="{FF2B5EF4-FFF2-40B4-BE49-F238E27FC236}">
-                <a16:creationId xmlns:a16="http://schemas.microsoft.com/office/drawing/2014/main" id="{7B6A6064-2F78-4050-B78A-AEB0A60020F3}"/>
+                <a16:creationId xmlns:a16="http://schemas.microsoft.com/office/drawing/2014/main" id="{71ED62FD-6DD7-4FA5-9E14-22BF222B0131}"/>
               </a:ext>
             </a:extLst>
           </p:cNvPr>
@@ -6752,7 +6752,7 @@
           <p:cNvPr id="10" name="">
             <a:extLst xmlns:a="http://schemas.openxmlformats.org/drawingml/2006/main">
               <a:ext uri="{FF2B5EF4-FFF2-40B4-BE49-F238E27FC236}">
-                <a16:creationId xmlns:a16="http://schemas.microsoft.com/office/drawing/2014/main" id="{72DC132B-0A08-416F-B9A9-042362294376}"/>
+                <a16:creationId xmlns:a16="http://schemas.microsoft.com/office/drawing/2014/main" id="{3E7F69DF-0E7B-4D70-AD97-182F7724C88D}"/>
               </a:ext>
             </a:extLst>
           </p:cNvPr>
@@ -6808,7 +6808,7 @@
     </p:spTree>
     <p:extLst>
       <p:ext uri="{BB962C8B-B14F-4D97-AF65-F5344CB8AC3E}">
-        <p14:creationId xmlns:p14="http://schemas.microsoft.com/office/powerpoint/2010/main" val="1585609413"/>
+        <p14:creationId xmlns:p14="http://schemas.microsoft.com/office/powerpoint/2010/main" val="2037868218"/>
       </p:ext>
     </p:extLst>
   </p:cSld>
@@ -6839,7 +6839,7 @@
           <p:cNvPr id="7" name="Google-Shape-532-p58-2">
             <a:extLst xmlns:a="http://schemas.openxmlformats.org/drawingml/2006/main">
               <a:ext uri="{FF2B5EF4-FFF2-40B4-BE49-F238E27FC236}">
-                <a16:creationId xmlns:a16="http://schemas.microsoft.com/office/drawing/2014/main" id="{1D751558-00DE-4DC6-ABD5-A9939A0ADF88}"/>
+                <a16:creationId xmlns:a16="http://schemas.microsoft.com/office/drawing/2014/main" id="{4865A58A-BE6C-4F77-9B62-5DB44221380F}"/>
               </a:ext>
             </a:extLst>
           </p:cNvPr>
@@ -6884,7 +6884,7 @@
           <p:cNvPr id="2" name="Google-Shape-533-p58-3">
             <a:extLst xmlns:a="http://schemas.openxmlformats.org/drawingml/2006/main">
               <a:ext uri="{FF2B5EF4-FFF2-40B4-BE49-F238E27FC236}">
-                <a16:creationId xmlns:a16="http://schemas.microsoft.com/office/drawing/2014/main" id="{0D08CEA1-BF35-4586-B710-4241F232A21A}"/>
+                <a16:creationId xmlns:a16="http://schemas.microsoft.com/office/drawing/2014/main" id="{8AB42372-BFB7-4AD8-AEE8-C28A33266C84}"/>
               </a:ext>
             </a:extLst>
           </p:cNvPr>
@@ -6944,7 +6944,7 @@
           <p:cNvPr id="3" name="Google-Shape-534-p58-4">
             <a:extLst xmlns:a="http://schemas.openxmlformats.org/drawingml/2006/main">
               <a:ext uri="{FF2B5EF4-FFF2-40B4-BE49-F238E27FC236}">
-                <a16:creationId xmlns:a16="http://schemas.microsoft.com/office/drawing/2014/main" id="{FF7C1EB0-E9BB-421D-BA0B-36BB5BD69BC6}"/>
+                <a16:creationId xmlns:a16="http://schemas.microsoft.com/office/drawing/2014/main" id="{5749781C-D72E-4D7D-82E8-11D4574124D0}"/>
               </a:ext>
             </a:extLst>
           </p:cNvPr>
@@ -7035,7 +7035,7 @@
           <p:cNvPr id="4" name="Content-Placeholder-3-5">
             <a:extLst xmlns:a="http://schemas.openxmlformats.org/drawingml/2006/main">
               <a:ext uri="{FF2B5EF4-FFF2-40B4-BE49-F238E27FC236}">
-                <a16:creationId xmlns:a16="http://schemas.microsoft.com/office/drawing/2014/main" id="{F841B1B1-64D1-406A-8DC5-FE4CB8F61172}"/>
+                <a16:creationId xmlns:a16="http://schemas.microsoft.com/office/drawing/2014/main" id="{95A589AC-A332-4F3F-B603-A009FB746A5E}"/>
               </a:ext>
             </a:extLst>
           </p:cNvPr>
@@ -7126,7 +7126,7 @@
           <p:cNvPr id="5" name="accent-6">
             <a:extLst xmlns:a="http://schemas.openxmlformats.org/drawingml/2006/main">
               <a:ext uri="{FF2B5EF4-FFF2-40B4-BE49-F238E27FC236}">
-                <a16:creationId xmlns:a16="http://schemas.microsoft.com/office/drawing/2014/main" id="{027C42A4-ECDC-45FA-8341-45DB24330375}"/>
+                <a16:creationId xmlns:a16="http://schemas.microsoft.com/office/drawing/2014/main" id="{A797F969-9ECF-4641-B45B-E914AB3D1AEE}"/>
               </a:ext>
             </a:extLst>
           </p:cNvPr>
@@ -7157,7 +7157,7 @@
           <p:cNvPr id="6" name="section-6">
             <a:extLst xmlns:a="http://schemas.openxmlformats.org/drawingml/2006/main">
               <a:ext uri="{FF2B5EF4-FFF2-40B4-BE49-F238E27FC236}">
-                <a16:creationId xmlns:a16="http://schemas.microsoft.com/office/drawing/2014/main" id="{823782B4-55BA-4B14-8F1C-D69FBF7E59DC}"/>
+                <a16:creationId xmlns:a16="http://schemas.microsoft.com/office/drawing/2014/main" id="{7F5AC6D1-25BD-46A0-A46E-4D4BE0CDB737}"/>
               </a:ext>
             </a:extLst>
           </p:cNvPr>
@@ -7211,7 +7211,7 @@
     </p:spTree>
     <p:extLst>
       <p:ext uri="{BB962C8B-B14F-4D97-AF65-F5344CB8AC3E}">
-        <p14:creationId xmlns:p14="http://schemas.microsoft.com/office/powerpoint/2010/main" val="691062523"/>
+        <p14:creationId xmlns:p14="http://schemas.microsoft.com/office/powerpoint/2010/main" val="480959905"/>
       </p:ext>
     </p:extLst>
   </p:cSld>
@@ -7242,7 +7242,7 @@
           <p:cNvPr id="7" name="Google-Shape-532-p58-2">
             <a:extLst xmlns:a="http://schemas.openxmlformats.org/drawingml/2006/main">
               <a:ext uri="{FF2B5EF4-FFF2-40B4-BE49-F238E27FC236}">
-                <a16:creationId xmlns:a16="http://schemas.microsoft.com/office/drawing/2014/main" id="{FB31236E-7F41-4956-9B7A-96E9363C9E9B}"/>
+                <a16:creationId xmlns:a16="http://schemas.microsoft.com/office/drawing/2014/main" id="{A769E4AB-CCAD-4CE3-B983-0BBBC3C70FF6}"/>
               </a:ext>
             </a:extLst>
           </p:cNvPr>
@@ -7287,7 +7287,7 @@
           <p:cNvPr id="2" name="Google-Shape-533-p58-3">
             <a:extLst xmlns:a="http://schemas.openxmlformats.org/drawingml/2006/main">
               <a:ext uri="{FF2B5EF4-FFF2-40B4-BE49-F238E27FC236}">
-                <a16:creationId xmlns:a16="http://schemas.microsoft.com/office/drawing/2014/main" id="{3DC12F93-0201-4D96-AB08-DECE648AD9BF}"/>
+                <a16:creationId xmlns:a16="http://schemas.microsoft.com/office/drawing/2014/main" id="{82DC5AEE-09F0-446F-BE10-1DF6F8D17CE7}"/>
               </a:ext>
             </a:extLst>
           </p:cNvPr>
@@ -7347,7 +7347,7 @@
           <p:cNvPr id="3" name="Google-Shape-534-p58-4">
             <a:extLst xmlns:a="http://schemas.openxmlformats.org/drawingml/2006/main">
               <a:ext uri="{FF2B5EF4-FFF2-40B4-BE49-F238E27FC236}">
-                <a16:creationId xmlns:a16="http://schemas.microsoft.com/office/drawing/2014/main" id="{A23E4CE2-278D-4134-9842-808CE5438A60}"/>
+                <a16:creationId xmlns:a16="http://schemas.microsoft.com/office/drawing/2014/main" id="{F063B375-A385-44EA-86F4-C1B07083D453}"/>
               </a:ext>
             </a:extLst>
           </p:cNvPr>
@@ -7428,7 +7428,7 @@
                 <a:cs typeface="Aptos"/>
               </a:rPr>
               <a:t>Xα − X̄
-Conecta la mejor solución con el centro de la población.</a:t>
+Lectura del equipo: conecta el mejor registro con el centro poblacional.</a:t>
             </a:r>
           </a:p>
         </p:txBody>
@@ -7438,7 +7438,7 @@
           <p:cNvPr id="4" name="Content-Placeholder-3-5">
             <a:extLst xmlns:a="http://schemas.openxmlformats.org/drawingml/2006/main">
               <a:ext uri="{FF2B5EF4-FFF2-40B4-BE49-F238E27FC236}">
-                <a16:creationId xmlns:a16="http://schemas.microsoft.com/office/drawing/2014/main" id="{00DB64C8-A543-45D1-BA7E-E4F7274545DA}"/>
+                <a16:creationId xmlns:a16="http://schemas.microsoft.com/office/drawing/2014/main" id="{00BE5A32-62CF-43DC-9E88-51144EF8EF2B}"/>
               </a:ext>
             </a:extLst>
           </p:cNvPr>
@@ -7529,7 +7529,7 @@
           <p:cNvPr id="5" name="accent-7">
             <a:extLst xmlns:a="http://schemas.openxmlformats.org/drawingml/2006/main">
               <a:ext uri="{FF2B5EF4-FFF2-40B4-BE49-F238E27FC236}">
-                <a16:creationId xmlns:a16="http://schemas.microsoft.com/office/drawing/2014/main" id="{C5E52569-1045-4AED-8CD3-E6F474F20875}"/>
+                <a16:creationId xmlns:a16="http://schemas.microsoft.com/office/drawing/2014/main" id="{2CF4E179-551B-4722-BFB2-69FF232249EF}"/>
               </a:ext>
             </a:extLst>
           </p:cNvPr>
@@ -7560,7 +7560,7 @@
           <p:cNvPr id="6" name="section-7">
             <a:extLst xmlns:a="http://schemas.openxmlformats.org/drawingml/2006/main">
               <a:ext uri="{FF2B5EF4-FFF2-40B4-BE49-F238E27FC236}">
-                <a16:creationId xmlns:a16="http://schemas.microsoft.com/office/drawing/2014/main" id="{2ECE8BFF-424A-4415-9154-F6C1594BD309}"/>
+                <a16:creationId xmlns:a16="http://schemas.microsoft.com/office/drawing/2014/main" id="{E74C79B3-E4B2-4794-AC31-A26323E0D074}"/>
               </a:ext>
             </a:extLst>
           </p:cNvPr>
@@ -7614,7 +7614,7 @@
     </p:spTree>
     <p:extLst>
       <p:ext uri="{BB962C8B-B14F-4D97-AF65-F5344CB8AC3E}">
-        <p14:creationId xmlns:p14="http://schemas.microsoft.com/office/powerpoint/2010/main" val="1585660753"/>
+        <p14:creationId xmlns:p14="http://schemas.microsoft.com/office/powerpoint/2010/main" val="1493174393"/>
       </p:ext>
     </p:extLst>
   </p:cSld>
@@ -7645,7 +7645,7 @@
           <p:cNvPr id="8" name="Google-Shape-532-p58-2">
             <a:extLst xmlns:a="http://schemas.openxmlformats.org/drawingml/2006/main">
               <a:ext uri="{FF2B5EF4-FFF2-40B4-BE49-F238E27FC236}">
-                <a16:creationId xmlns:a16="http://schemas.microsoft.com/office/drawing/2014/main" id="{8B6FACAD-6AF0-4B6D-8A44-0A3AA92D8F45}"/>
+                <a16:creationId xmlns:a16="http://schemas.microsoft.com/office/drawing/2014/main" id="{DBA25DD0-8DFE-4823-A9E6-426EEF362F62}"/>
               </a:ext>
             </a:extLst>
           </p:cNvPr>
@@ -7690,7 +7690,7 @@
           <p:cNvPr id="2" name="Google-Shape-533-p58-3">
             <a:extLst xmlns:a="http://schemas.openxmlformats.org/drawingml/2006/main">
               <a:ext uri="{FF2B5EF4-FFF2-40B4-BE49-F238E27FC236}">
-                <a16:creationId xmlns:a16="http://schemas.microsoft.com/office/drawing/2014/main" id="{02E18546-73AB-411A-A2C4-F010D321CD93}"/>
+                <a16:creationId xmlns:a16="http://schemas.microsoft.com/office/drawing/2014/main" id="{DCB421BD-1653-4346-A9DE-0E1D8E14B1AC}"/>
               </a:ext>
             </a:extLst>
           </p:cNvPr>
@@ -7750,7 +7750,7 @@
           <p:cNvPr id="3" name="Google-Shape-534-p58-4">
             <a:extLst xmlns:a="http://schemas.openxmlformats.org/drawingml/2006/main">
               <a:ext uri="{FF2B5EF4-FFF2-40B4-BE49-F238E27FC236}">
-                <a16:creationId xmlns:a16="http://schemas.microsoft.com/office/drawing/2014/main" id="{23C969D6-1D1C-453F-82A6-7CAA0D29A400}"/>
+                <a16:creationId xmlns:a16="http://schemas.microsoft.com/office/drawing/2014/main" id="{DEF3419A-FEC3-4BCC-9081-70B9FA89B40C}"/>
               </a:ext>
             </a:extLst>
           </p:cNvPr>
@@ -7842,7 +7842,7 @@
           <p:cNvPr id="4" name="Content-Placeholder-3-5">
             <a:extLst xmlns:a="http://schemas.openxmlformats.org/drawingml/2006/main">
               <a:ext uri="{FF2B5EF4-FFF2-40B4-BE49-F238E27FC236}">
-                <a16:creationId xmlns:a16="http://schemas.microsoft.com/office/drawing/2014/main" id="{49D42FAD-152F-461D-B20F-49A4F01ACB50}"/>
+                <a16:creationId xmlns:a16="http://schemas.microsoft.com/office/drawing/2014/main" id="{347D5459-E9D5-4707-B675-6ADCA4ABE483}"/>
               </a:ext>
             </a:extLst>
           </p:cNvPr>
@@ -7933,7 +7933,7 @@
           <p:cNvPr id="5" name="accent-8">
             <a:extLst xmlns:a="http://schemas.openxmlformats.org/drawingml/2006/main">
               <a:ext uri="{FF2B5EF4-FFF2-40B4-BE49-F238E27FC236}">
-                <a16:creationId xmlns:a16="http://schemas.microsoft.com/office/drawing/2014/main" id="{2B0B0305-2B09-4AA2-AB39-5C13843BBB32}"/>
+                <a16:creationId xmlns:a16="http://schemas.microsoft.com/office/drawing/2014/main" id="{26AE2DBC-4540-4B31-BFAB-BCFAC335066B}"/>
               </a:ext>
             </a:extLst>
           </p:cNvPr>
@@ -7964,7 +7964,7 @@
           <p:cNvPr id="6" name="section-8">
             <a:extLst xmlns:a="http://schemas.openxmlformats.org/drawingml/2006/main">
               <a:ext uri="{FF2B5EF4-FFF2-40B4-BE49-F238E27FC236}">
-                <a16:creationId xmlns:a16="http://schemas.microsoft.com/office/drawing/2014/main" id="{B74C69A6-35DF-4892-9998-16EC370A574B}"/>
+                <a16:creationId xmlns:a16="http://schemas.microsoft.com/office/drawing/2014/main" id="{20C96D08-F997-49A6-BF03-29B08032103A}"/>
               </a:ext>
             </a:extLst>
           </p:cNvPr>
@@ -8020,7 +8020,7 @@
           <p:cNvPr id="7" name="answer-callout">
             <a:extLst xmlns:a="http://schemas.openxmlformats.org/drawingml/2006/main">
               <a:ext uri="{FF2B5EF4-FFF2-40B4-BE49-F238E27FC236}">
-                <a16:creationId xmlns:a16="http://schemas.microsoft.com/office/drawing/2014/main" id="{1838A5C2-E679-4316-8960-7AC62484B840}"/>
+                <a16:creationId xmlns:a16="http://schemas.microsoft.com/office/drawing/2014/main" id="{BF6563A5-2048-454C-BCF8-718D0E21CFB2}"/>
               </a:ext>
             </a:extLst>
           </p:cNvPr>
@@ -8074,7 +8074,7 @@
     </p:spTree>
     <p:extLst>
       <p:ext uri="{BB962C8B-B14F-4D97-AF65-F5344CB8AC3E}">
-        <p14:creationId xmlns:p14="http://schemas.microsoft.com/office/powerpoint/2010/main" val="1988203009"/>
+        <p14:creationId xmlns:p14="http://schemas.microsoft.com/office/powerpoint/2010/main" val="521379765"/>
       </p:ext>
     </p:extLst>
   </p:cSld>
@@ -8105,7 +8105,7 @@
           <p:cNvPr id="9" name="Google-Shape-532-p58-2">
             <a:extLst xmlns:a="http://schemas.openxmlformats.org/drawingml/2006/main">
               <a:ext uri="{FF2B5EF4-FFF2-40B4-BE49-F238E27FC236}">
-                <a16:creationId xmlns:a16="http://schemas.microsoft.com/office/drawing/2014/main" id="{90994452-9B30-4E60-B699-CF7EB38D39AB}"/>
+                <a16:creationId xmlns:a16="http://schemas.microsoft.com/office/drawing/2014/main" id="{1805FC73-D71C-4724-9B9E-73C65EA4F2FC}"/>
               </a:ext>
             </a:extLst>
           </p:cNvPr>
@@ -8150,7 +8150,7 @@
           <p:cNvPr id="2" name="Google-Shape-533-p58-3">
             <a:extLst xmlns:a="http://schemas.openxmlformats.org/drawingml/2006/main">
               <a:ext uri="{FF2B5EF4-FFF2-40B4-BE49-F238E27FC236}">
-                <a16:creationId xmlns:a16="http://schemas.microsoft.com/office/drawing/2014/main" id="{55B2D394-F764-4E9B-BACB-0D229F479246}"/>
+                <a16:creationId xmlns:a16="http://schemas.microsoft.com/office/drawing/2014/main" id="{D20C640F-44CC-44BE-827A-690D252970AA}"/>
               </a:ext>
             </a:extLst>
           </p:cNvPr>
@@ -8210,7 +8210,7 @@
           <p:cNvPr id="3" name="Content-Placeholder-15-4">
             <a:extLst xmlns:a="http://schemas.openxmlformats.org/drawingml/2006/main">
               <a:ext uri="{FF2B5EF4-FFF2-40B4-BE49-F238E27FC236}">
-                <a16:creationId xmlns:a16="http://schemas.microsoft.com/office/drawing/2014/main" id="{2DC9E392-E0ED-440F-B4D4-79F19247B732}"/>
+                <a16:creationId xmlns:a16="http://schemas.microsoft.com/office/drawing/2014/main" id="{EF328713-DDB0-431B-B086-B24E86731A13}"/>
               </a:ext>
             </a:extLst>
           </p:cNvPr>
@@ -8300,7 +8300,7 @@
           <p:cNvPr id="4" name="route-table-cover">
             <a:extLst xmlns:a="http://schemas.openxmlformats.org/drawingml/2006/main">
               <a:ext uri="{FF2B5EF4-FFF2-40B4-BE49-F238E27FC236}">
-                <a16:creationId xmlns:a16="http://schemas.microsoft.com/office/drawing/2014/main" id="{DDBC5C0C-2AE9-4AE2-9810-7EC026DB6E12}"/>
+                <a16:creationId xmlns:a16="http://schemas.microsoft.com/office/drawing/2014/main" id="{C5D6BDD3-6724-4E54-B945-F72F2A21780D}"/>
               </a:ext>
             </a:extLst>
           </p:cNvPr>
@@ -8847,7 +8847,7 @@
           <p:cNvPr id="6" name="route-equation">
             <a:extLst xmlns:a="http://schemas.openxmlformats.org/drawingml/2006/main">
               <a:ext uri="{FF2B5EF4-FFF2-40B4-BE49-F238E27FC236}">
-                <a16:creationId xmlns:a16="http://schemas.microsoft.com/office/drawing/2014/main" id="{89C8AF3D-A034-48CF-8DA2-82CDA37E4383}"/>
+                <a16:creationId xmlns:a16="http://schemas.microsoft.com/office/drawing/2014/main" id="{CCD097A5-C171-4224-87FE-B68E163957D7}"/>
               </a:ext>
             </a:extLst>
           </p:cNvPr>
@@ -8903,7 +8903,7 @@
           <p:cNvPr id="7" name="accent-9">
             <a:extLst xmlns:a="http://schemas.openxmlformats.org/drawingml/2006/main">
               <a:ext uri="{FF2B5EF4-FFF2-40B4-BE49-F238E27FC236}">
-                <a16:creationId xmlns:a16="http://schemas.microsoft.com/office/drawing/2014/main" id="{F47F9A5B-14E5-48DF-B7D1-B459C85993E2}"/>
+                <a16:creationId xmlns:a16="http://schemas.microsoft.com/office/drawing/2014/main" id="{378906F2-BEB1-4CE4-9C69-EF74170085D2}"/>
               </a:ext>
             </a:extLst>
           </p:cNvPr>
@@ -8934,7 +8934,7 @@
           <p:cNvPr id="8" name="section-9">
             <a:extLst xmlns:a="http://schemas.openxmlformats.org/drawingml/2006/main">
               <a:ext uri="{FF2B5EF4-FFF2-40B4-BE49-F238E27FC236}">
-                <a16:creationId xmlns:a16="http://schemas.microsoft.com/office/drawing/2014/main" id="{EC81265F-AA16-4844-B432-D64543A83018}"/>
+                <a16:creationId xmlns:a16="http://schemas.microsoft.com/office/drawing/2014/main" id="{0206D2C0-13CA-4577-9E57-4F72B39A3220}"/>
               </a:ext>
             </a:extLst>
           </p:cNvPr>
@@ -8988,7 +8988,7 @@
     </p:spTree>
     <p:extLst>
       <p:ext uri="{BB962C8B-B14F-4D97-AF65-F5344CB8AC3E}">
-        <p14:creationId xmlns:p14="http://schemas.microsoft.com/office/powerpoint/2010/main" val="1517038820"/>
+        <p14:creationId xmlns:p14="http://schemas.microsoft.com/office/powerpoint/2010/main" val="347537061"/>
       </p:ext>
     </p:extLst>
   </p:cSld>

</xml_diff>